<commit_message>
Sales kit refreshed: new contact, current screenshots, scripted media regen
- docs/media/*.png reshot from the current build in demo mode (2x, via the
  new scripts/media-shots.mjs — Playwright, same pattern as the digest
  renderer) so the deck and proposals show today's product: game-day
  guide, ticket links, storylines, the works.
- sponsor-deck.pptx regenerated: weber.chris contact on both contact
  slides, game-day guide in the inventory, stale calendar credit gone.

Co-Authored-By: Claude Fable 5 <noreply@anthropic.com>
</commit_message>
<xml_diff>
--- a/docs/sponsor-deck.pptx
+++ b/docs/sponsor-deck.pptx
@@ -1674,7 +1674,7 @@
                 <a:ea typeface="Calibri" pitchFamily="34" charset="-122"/>
                 <a:cs typeface="Calibri" pitchFamily="34" charset="-120"/>
               </a:rPr>
-              <a:t>wausaupilotandreview.com   ·   sales@wausaupilotandreview.com</a:t>
+              <a:t>wausaupilotandreview.com   ·   weber.chris@wausaupilotandreview.com</a:t>
             </a:r>
             <a:endParaRPr lang="en-US" sz="1050" dirty="0"/>
           </a:p>
@@ -1702,7 +1702,7 @@
       </p:sp>
       <p:pic>
         <p:nvPicPr>
-          <p:cNvPr id="7" name="Image 0" descr="/home/user/wpr-packers-tracker/public/og-card.png">    </p:cNvPr>
+          <p:cNvPr id="7" name="Image 0" descr="C:\Users\rpfly\Projects\wpr-packers-tracker\public\og-card.png">    </p:cNvPr>
           <p:cNvPicPr>
             <a:picLocks noChangeAspect="1"/>
           </p:cNvPicPr>
@@ -4251,7 +4251,7 @@
                 <a:ea typeface="Calibri" pitchFamily="34" charset="-122"/>
                 <a:cs typeface="Calibri" pitchFamily="34" charset="-120"/>
               </a:rPr>
-              <a:t>Where to watch · venue listing</a:t>
+              <a:t>Game-day guide · venue listings</a:t>
             </a:r>
             <a:endParaRPr lang="en-US" sz="850" dirty="0"/>
           </a:p>
@@ -4547,7 +4547,7 @@
                 <a:ea typeface="Calibri" pitchFamily="34" charset="-122"/>
                 <a:cs typeface="Calibri" pitchFamily="34" charset="-120"/>
               </a:rPr>
-              <a:t>Banner lockup + hero credit + email digest logo + calendar credit</a:t>
+              <a:t>Banner lockup + hero credit + email digest logo</a:t>
             </a:r>
             <a:endParaRPr lang="en-US" sz="950" dirty="0"/>
           </a:p>
@@ -5180,7 +5180,7 @@
                 <a:ea typeface="Calibri" pitchFamily="34" charset="-122"/>
                 <a:cs typeface="Calibri" pitchFamily="34" charset="-120"/>
               </a:rPr>
-              <a:t>Where to watch</a:t>
+              <a:t>Game-day guide</a:t>
             </a:r>
             <a:endParaRPr lang="en-US" sz="1200" dirty="0"/>
           </a:p>
@@ -5219,7 +5219,7 @@
                 <a:ea typeface="Calibri" pitchFamily="34" charset="-122"/>
                 <a:cs typeface="Calibri" pitchFamily="34" charset="-120"/>
               </a:rPr>
-              <a:t>A full venue listing: photo, amenities, game-day specials</a:t>
+              <a:t>Venue listings sold per listing: photos, amenity chips, game-day specials</a:t>
             </a:r>
             <a:endParaRPr lang="en-US" sz="950" dirty="0"/>
           </a:p>
@@ -5431,7 +5431,7 @@
         <p:spPr>
           <a:xfrm>
             <a:off x="493776" y="1298448"/>
-            <a:ext cx="4992624" cy="1694434"/>
+            <a:ext cx="4992624" cy="1608277"/>
           </a:xfrm>
           <a:prstGeom prst="rect">
             <a:avLst/>
@@ -5456,7 +5456,7 @@
       </p:sp>
       <p:pic>
         <p:nvPicPr>
-          <p:cNvPr id="5" name="Image 0" descr="/home/user/wpr-packers-tracker/docs/media/banner-demo.png">    </p:cNvPr>
+          <p:cNvPr id="5" name="Image 0" descr="C:\Users\rpfly\Projects\wpr-packers-tracker\docs\media\banner-demo.png">    </p:cNvPr>
           <p:cNvPicPr>
             <a:picLocks noChangeAspect="1"/>
           </p:cNvPicPr>
@@ -5471,7 +5471,7 @@
         <p:spPr>
           <a:xfrm>
             <a:off x="566928" y="1371600"/>
-            <a:ext cx="4846320" cy="1548130"/>
+            <a:ext cx="4846320" cy="1461973"/>
           </a:xfrm>
           <a:prstGeom prst="rect">
             <a:avLst/>
@@ -5487,7 +5487,7 @@
         <p:spPr>
           <a:xfrm>
             <a:off x="493776" y="3035808"/>
-            <a:ext cx="4306824" cy="1939632"/>
+            <a:ext cx="4306824" cy="1934337"/>
           </a:xfrm>
           <a:prstGeom prst="rect">
             <a:avLst/>
@@ -5512,7 +5512,7 @@
       </p:sp>
       <p:pic>
         <p:nvPicPr>
-          <p:cNvPr id="7" name="Image 1" descr="/home/user/wpr-packers-tracker/docs/media/hero.png">    </p:cNvPr>
+          <p:cNvPr id="7" name="Image 1" descr="C:\Users\rpfly\Projects\wpr-packers-tracker\docs\media\hero.png">    </p:cNvPr>
           <p:cNvPicPr>
             <a:picLocks noChangeAspect="1"/>
           </p:cNvPicPr>
@@ -5527,7 +5527,7 @@
         <p:spPr>
           <a:xfrm>
             <a:off x="566928" y="3108960"/>
-            <a:ext cx="4160520" cy="1793328"/>
+            <a:ext cx="4160520" cy="1788033"/>
           </a:xfrm>
           <a:prstGeom prst="rect">
             <a:avLst/>
@@ -5543,7 +5543,7 @@
         <p:spPr>
           <a:xfrm>
             <a:off x="5916168" y="1298448"/>
-            <a:ext cx="2478024" cy="1822922"/>
+            <a:ext cx="2478024" cy="1834025"/>
           </a:xfrm>
           <a:prstGeom prst="rect">
             <a:avLst/>
@@ -5568,7 +5568,7 @@
       </p:sp>
       <p:pic>
         <p:nvPicPr>
-          <p:cNvPr id="9" name="Image 2" descr="/home/user/wpr-packers-tracker/docs/media/mini-digest.png">    </p:cNvPr>
+          <p:cNvPr id="9" name="Image 2" descr="C:\Users\rpfly\Projects\wpr-packers-tracker\docs\media\mini-digest.png">    </p:cNvPr>
           <p:cNvPicPr>
             <a:picLocks noChangeAspect="1"/>
           </p:cNvPicPr>
@@ -5583,7 +5583,7 @@
         <p:spPr>
           <a:xfrm>
             <a:off x="5989320" y="1371600"/>
-            <a:ext cx="2331720" cy="1676618"/>
+            <a:ext cx="2331720" cy="1687721"/>
           </a:xfrm>
           <a:prstGeom prst="rect">
             <a:avLst/>
@@ -6273,7 +6273,7 @@
       </p:sp>
       <p:pic>
         <p:nvPicPr>
-          <p:cNvPr id="21" name="Image 4" descr="/home/user/wpr-packers-tracker/public/og-card.png">    </p:cNvPr>
+          <p:cNvPr id="21" name="Image 4" descr="C:\Users\rpfly\Projects\wpr-packers-tracker\public\og-card.png">    </p:cNvPr>
           <p:cNvPicPr>
             <a:picLocks noChangeAspect="1"/>
           </p:cNvPicPr>
@@ -7451,7 +7451,7 @@
                 <a:ea typeface="Calibri" pitchFamily="34" charset="-122"/>
                 <a:cs typeface="Calibri" pitchFamily="34" charset="-120"/>
               </a:rPr>
-              <a:t>sales@wausaupilotandreview.com</a:t>
+              <a:t>weber.chris@wausaupilotandreview.com</a:t>
             </a:r>
             <a:endParaRPr lang="en-US" sz="1400" dirty="0"/>
           </a:p>

</xml_diff>

<commit_message>
Sales kit reshot with the press-seal masthead
docs/media and the deck regenerated from the current build: typewriter
badge in the masthead, demo ribbon visible on the banner shot (it labels
the preview as exactly that), current contact throughout.

Co-Authored-By: Claude Fable 5 <noreply@anthropic.com>
</commit_message>
<xml_diff>
--- a/docs/sponsor-deck.pptx
+++ b/docs/sponsor-deck.pptx
@@ -5431,7 +5431,7 @@
         <p:spPr>
           <a:xfrm>
             <a:off x="493776" y="1298448"/>
-            <a:ext cx="4992624" cy="1608277"/>
+            <a:ext cx="4992624" cy="1761744"/>
           </a:xfrm>
           <a:prstGeom prst="rect">
             <a:avLst/>
@@ -5471,7 +5471,7 @@
         <p:spPr>
           <a:xfrm>
             <a:off x="566928" y="1371600"/>
-            <a:ext cx="4846320" cy="1461973"/>
+            <a:ext cx="4846320" cy="1615440"/>
           </a:xfrm>
           <a:prstGeom prst="rect">
             <a:avLst/>

</xml_diff>

<commit_message>
Media shots: same ESPN headless proxy; sales kit reshot with the slate
scripts/media-shots.mjs had the same two latent breaks as the digest
render: no answer to ESPN's headless-CORS fingerprinting (every shot
would have rendered its data sections empty on the next reshoot) and a
mini-digest wait pinned to the standings <table> that the preseason
slate replaces during the exhibition window. Same fixes: proxy
*.espn.com API calls through Node's fetch per page, and accept table
OR slate as the digest's data-ready signal.

docs/media and the sponsor deck are regenerated with the fixed script,
so the sales kit now shows the August product: preseason hero, digest
with the exhibition slate, film room intact.

Co-Authored-By: Claude Fable 5 <noreply@anthropic.com>
</commit_message>
<xml_diff>
--- a/docs/sponsor-deck.pptx
+++ b/docs/sponsor-deck.pptx
@@ -5543,7 +5543,7 @@
         <p:spPr>
           <a:xfrm>
             <a:off x="5916168" y="1298448"/>
-            <a:ext cx="2478024" cy="1834025"/>
+            <a:ext cx="2478024" cy="1639715"/>
           </a:xfrm>
           <a:prstGeom prst="rect">
             <a:avLst/>
@@ -5583,7 +5583,7 @@
         <p:spPr>
           <a:xfrm>
             <a:off x="5989320" y="1371600"/>
-            <a:ext cx="2331720" cy="1687721"/>
+            <a:ext cx="2331720" cy="1493411"/>
           </a:xfrm>
           <a:prstGeom prst="rect">
             <a:avLst/>

</xml_diff>